<commit_message>
Issue #1/#5: enriquecer el corpus y consistencia de citas
Documentos (más planes y detalle):
- comparativa_planes.csv: nuevo plan Starter + ~27 características comparadas.
- planes_y_precios.xlsx: hojas Planes, Add-ons, Descuentos y Detalle por plan.
- base_conocimiento.md: sección de planes, seguridad, reportes, móvil, más detalle.
- integraciones_api.json: más endpoints, integraciones, webhooks y códigos de error.
- faq_soporte.html: muchas más FAQ (reembolsos, descuentos, datos, idiomas...).
- onboarding_producto.pptx, terminos_de_uso.docx, politica_privacidad.pdf ampliados.

Generación:
- _remap_citations: renumera los [n] del texto para que coincidan exactamente con
  la lista de fuentes citadas y deduplica por archivo (reemplaza a _cited_sources).

Co-Authored-By: Claude Opus 4.8 (1M context) <noreply@anthropic.com>
</commit_message>
<xml_diff>
--- a/data/documents/producto/onboarding_producto.pptx
+++ b/data/documents/producto/onboarding_producto.pptx
@@ -8,6 +8,9 @@
     <p:sldId id="256" r:id="rId7"/>
     <p:sldId id="257" r:id="rId8"/>
     <p:sldId id="258" r:id="rId9"/>
+    <p:sldId id="259" r:id="rId10"/>
+    <p:sldId id="260" r:id="rId11"/>
+    <p:sldId id="261" r:id="rId12"/>
   </p:sldIdLst>
   <p:sldSz cx="9144000" cy="6858000" type="screen4x3"/>
   <p:notesSz cx="6858000" cy="9144000"/>
@@ -3092,42 +3095,47 @@
       <p:grpSpPr/>
       <p:sp>
         <p:nvSpPr>
-          <p:cNvPr id="2" name="Title 1"/>
-          <p:cNvSpPr>
-            <a:spLocks noGrp="1"/>
-          </p:cNvSpPr>
-          <p:nvPr>
-            <p:ph type="ctrTitle"/>
-          </p:nvPr>
-        </p:nvSpPr>
-        <p:spPr/>
-        <p:txBody>
-          <a:bodyPr/>
-          <a:lstStyle/>
-          <a:p>
+          <p:cNvPr id="2" name="TextBox 1"/>
+          <p:cNvSpPr txBox="1"/>
+          <p:nvPr/>
+        </p:nvSpPr>
+        <p:spPr>
+          <a:xfrm>
+            <a:off x="548640" y="365760"/>
+            <a:ext cx="8229600" cy="5486400"/>
+          </a:xfrm>
+          <a:prstGeom prst="rect">
+            <a:avLst/>
+          </a:prstGeom>
+          <a:noFill/>
+        </p:spPr>
+        <p:txBody>
+          <a:bodyPr wrap="square">
+            <a:spAutoFit/>
+          </a:bodyPr>
+          <a:lstStyle/>
+          <a:p>
+            <a:pPr>
+              <a:defRPr sz="3000" b="1"/>
+            </a:pPr>
             <a:r>
               <a:t>Bienvenido a TechNova</a:t>
             </a:r>
           </a:p>
-        </p:txBody>
-      </p:sp>
-      <p:sp>
-        <p:nvSpPr>
-          <p:cNvPr id="3" name="Subtitle 2"/>
-          <p:cNvSpPr>
-            <a:spLocks noGrp="1"/>
-          </p:cNvSpPr>
-          <p:nvPr>
-            <p:ph type="subTitle" idx="1"/>
-          </p:nvPr>
-        </p:nvSpPr>
-        <p:spPr/>
-        <p:txBody>
-          <a:bodyPr/>
-          <a:lstStyle/>
-          <a:p>
+          <a:p>
+            <a:pPr>
+              <a:defRPr sz="1800"/>
+            </a:pPr>
             <a:r>
               <a:t>Primeros pasos para tu equipo</a:t>
+            </a:r>
+          </a:p>
+          <a:p>
+            <a:pPr>
+              <a:defRPr sz="1800"/>
+            </a:pPr>
+            <a:r>
+              <a:t>Gestión de proyectos y colaboración</a:t>
             </a:r>
           </a:p>
         </p:txBody>
@@ -3152,55 +3160,61 @@
       <p:grpSpPr/>
       <p:sp>
         <p:nvSpPr>
-          <p:cNvPr id="2" name="Title 1"/>
-          <p:cNvSpPr>
-            <a:spLocks noGrp="1"/>
-          </p:cNvSpPr>
-          <p:nvPr>
-            <p:ph type="title"/>
-          </p:nvPr>
-        </p:nvSpPr>
-        <p:spPr/>
-        <p:txBody>
-          <a:bodyPr/>
-          <a:lstStyle/>
-          <a:p>
+          <p:cNvPr id="2" name="TextBox 1"/>
+          <p:cNvSpPr txBox="1"/>
+          <p:nvPr/>
+        </p:nvSpPr>
+        <p:spPr>
+          <a:xfrm>
+            <a:off x="548640" y="365760"/>
+            <a:ext cx="8229600" cy="5486400"/>
+          </a:xfrm>
+          <a:prstGeom prst="rect">
+            <a:avLst/>
+          </a:prstGeom>
+          <a:noFill/>
+        </p:spPr>
+        <p:txBody>
+          <a:bodyPr wrap="square">
+            <a:spAutoFit/>
+          </a:bodyPr>
+          <a:lstStyle/>
+          <a:p>
+            <a:pPr>
+              <a:defRPr sz="3000" b="1"/>
+            </a:pPr>
             <a:r>
               <a:t>Configura tu workspace</a:t>
             </a:r>
           </a:p>
-        </p:txBody>
-      </p:sp>
-      <p:sp>
-        <p:nvSpPr>
-          <p:cNvPr id="3" name="Content Placeholder 2"/>
-          <p:cNvSpPr>
-            <a:spLocks noGrp="1"/>
-          </p:cNvSpPr>
-          <p:nvPr>
-            <p:ph idx="1"/>
-          </p:nvPr>
-        </p:nvSpPr>
-        <p:spPr/>
-        <p:txBody>
-          <a:bodyPr/>
-          <a:lstStyle/>
-          <a:p>
+          <a:p>
+            <a:pPr>
+              <a:defRPr sz="1800"/>
+            </a:pPr>
             <a:r>
               <a:t>1. Crea tu primer proyecto</a:t>
             </a:r>
           </a:p>
           <a:p>
+            <a:pPr>
+              <a:defRPr sz="1800"/>
+            </a:pPr>
             <a:r>
               <a:t>2. Invita a tu equipo desde Configuración → Miembros</a:t>
             </a:r>
           </a:p>
           <a:p>
+            <a:pPr>
+              <a:defRPr sz="1800"/>
+            </a:pPr>
             <a:r>
               <a:t>3. Crea tareas y asígnalas con fecha límite</a:t>
             </a:r>
           </a:p>
           <a:p>
+            <a:pPr>
+              <a:defRPr sz="1800"/>
+            </a:pPr>
             <a:r>
               <a:t>4. Organiza el trabajo en un tablero Kanban</a:t>
             </a:r>
@@ -3227,57 +3241,314 @@
       <p:grpSpPr/>
       <p:sp>
         <p:nvSpPr>
-          <p:cNvPr id="2" name="Title 1"/>
-          <p:cNvSpPr>
-            <a:spLocks noGrp="1"/>
-          </p:cNvSpPr>
-          <p:nvPr>
-            <p:ph type="title"/>
-          </p:nvPr>
-        </p:nvSpPr>
-        <p:spPr/>
-        <p:txBody>
-          <a:bodyPr/>
-          <a:lstStyle/>
-          <a:p>
+          <p:cNvPr id="2" name="TextBox 1"/>
+          <p:cNvSpPr txBox="1"/>
+          <p:nvPr/>
+        </p:nvSpPr>
+        <p:spPr>
+          <a:xfrm>
+            <a:off x="548640" y="365760"/>
+            <a:ext cx="8229600" cy="5486400"/>
+          </a:xfrm>
+          <a:prstGeom prst="rect">
+            <a:avLst/>
+          </a:prstGeom>
+          <a:noFill/>
+        </p:spPr>
+        <p:txBody>
+          <a:bodyPr wrap="square">
+            <a:spAutoFit/>
+          </a:bodyPr>
+          <a:lstStyle/>
+          <a:p>
+            <a:pPr>
+              <a:defRPr sz="3000" b="1"/>
+            </a:pPr>
+            <a:r>
+              <a:t>Vistas para cada equipo</a:t>
+            </a:r>
+          </a:p>
+          <a:p>
+            <a:pPr>
+              <a:defRPr sz="1800"/>
+            </a:pPr>
+            <a:r>
+              <a:t>Kanban: flujo por estados</a:t>
+            </a:r>
+          </a:p>
+          <a:p>
+            <a:pPr>
+              <a:defRPr sz="1800"/>
+            </a:pPr>
+            <a:r>
+              <a:t>Lista: tareas en formato tabla</a:t>
+            </a:r>
+          </a:p>
+          <a:p>
+            <a:pPr>
+              <a:defRPr sz="1800"/>
+            </a:pPr>
+            <a:r>
+              <a:t>Calendario: por fecha límite</a:t>
+            </a:r>
+          </a:p>
+          <a:p>
+            <a:pPr>
+              <a:defRPr sz="1800"/>
+            </a:pPr>
+            <a:r>
+              <a:t>Gantt (Pro+): cronograma y dependencias</a:t>
+            </a:r>
+          </a:p>
+          <a:p>
+            <a:pPr>
+              <a:defRPr sz="1800"/>
+            </a:pPr>
+            <a:r>
+              <a:t>Carga de trabajo: balancea el equipo</a:t>
+            </a:r>
+          </a:p>
+        </p:txBody>
+      </p:sp>
+    </p:spTree>
+  </p:cSld>
+  <p:clrMapOvr>
+    <a:masterClrMapping/>
+  </p:clrMapOvr>
+</p:sld>
+</file>
+
+<file path=ppt/slides/slide4.xml><?xml version="1.0" encoding="utf-8"?>
+<p:sld xmlns:a="http://schemas.openxmlformats.org/drawingml/2006/main" xmlns:p="http://schemas.openxmlformats.org/presentationml/2006/main" xmlns:r="http://schemas.openxmlformats.org/officeDocument/2006/relationships">
+  <p:cSld>
+    <p:spTree>
+      <p:nvGrpSpPr>
+        <p:cNvPr id="1" name=""/>
+        <p:cNvGrpSpPr/>
+        <p:nvPr/>
+      </p:nvGrpSpPr>
+      <p:grpSpPr/>
+      <p:sp>
+        <p:nvSpPr>
+          <p:cNvPr id="2" name="TextBox 1"/>
+          <p:cNvSpPr txBox="1"/>
+          <p:nvPr/>
+        </p:nvSpPr>
+        <p:spPr>
+          <a:xfrm>
+            <a:off x="548640" y="365760"/>
+            <a:ext cx="8229600" cy="5486400"/>
+          </a:xfrm>
+          <a:prstGeom prst="rect">
+            <a:avLst/>
+          </a:prstGeom>
+          <a:noFill/>
+        </p:spPr>
+        <p:txBody>
+          <a:bodyPr wrap="square">
+            <a:spAutoFit/>
+          </a:bodyPr>
+          <a:lstStyle/>
+          <a:p>
+            <a:pPr>
+              <a:defRPr sz="3000" b="1"/>
+            </a:pPr>
             <a:r>
               <a:t>Saca más provecho</a:t>
             </a:r>
           </a:p>
-        </p:txBody>
-      </p:sp>
-      <p:sp>
-        <p:nvSpPr>
-          <p:cNvPr id="3" name="Content Placeholder 2"/>
-          <p:cNvSpPr>
-            <a:spLocks noGrp="1"/>
-          </p:cNvSpPr>
-          <p:nvPr>
-            <p:ph idx="1"/>
-          </p:nvPr>
-        </p:nvSpPr>
-        <p:spPr/>
-        <p:txBody>
-          <a:bodyPr/>
-          <a:lstStyle/>
-          <a:p>
+          <a:p>
+            <a:pPr>
+              <a:defRPr sz="1800"/>
+            </a:pPr>
             <a:r>
               <a:t>Activa automatizaciones para tareas repetitivas</a:t>
             </a:r>
           </a:p>
           <a:p>
+            <a:pPr>
+              <a:defRPr sz="1800"/>
+            </a:pPr>
             <a:r>
               <a:t>Conecta Slack y Google Drive</a:t>
             </a:r>
           </a:p>
           <a:p>
+            <a:pPr>
+              <a:defRPr sz="1800"/>
+            </a:pPr>
+            <a:r>
+              <a:t>Usa plantillas de proyecto</a:t>
+            </a:r>
+          </a:p>
+          <a:p>
+            <a:pPr>
+              <a:defRPr sz="1800"/>
+            </a:pPr>
+            <a:r>
+              <a:t>Registra el tiempo y revisa reportes</a:t>
+            </a:r>
+          </a:p>
+          <a:p>
+            <a:pPr>
+              <a:defRPr sz="1800"/>
+            </a:pPr>
             <a:r>
               <a:t>Activa la verificación en dos pasos (2FA)</a:t>
             </a:r>
           </a:p>
-          <a:p>
-            <a:r>
-              <a:t>Explora las vistas Calendario y Gantt</a:t>
+        </p:txBody>
+      </p:sp>
+    </p:spTree>
+  </p:cSld>
+  <p:clrMapOvr>
+    <a:masterClrMapping/>
+  </p:clrMapOvr>
+</p:sld>
+</file>
+
+<file path=ppt/slides/slide5.xml><?xml version="1.0" encoding="utf-8"?>
+<p:sld xmlns:a="http://schemas.openxmlformats.org/drawingml/2006/main" xmlns:p="http://schemas.openxmlformats.org/presentationml/2006/main" xmlns:r="http://schemas.openxmlformats.org/officeDocument/2006/relationships">
+  <p:cSld>
+    <p:spTree>
+      <p:nvGrpSpPr>
+        <p:cNvPr id="1" name=""/>
+        <p:cNvGrpSpPr/>
+        <p:nvPr/>
+      </p:nvGrpSpPr>
+      <p:grpSpPr/>
+      <p:sp>
+        <p:nvSpPr>
+          <p:cNvPr id="2" name="TextBox 1"/>
+          <p:cNvSpPr txBox="1"/>
+          <p:nvPr/>
+        </p:nvSpPr>
+        <p:spPr>
+          <a:xfrm>
+            <a:off x="548640" y="365760"/>
+            <a:ext cx="8229600" cy="5486400"/>
+          </a:xfrm>
+          <a:prstGeom prst="rect">
+            <a:avLst/>
+          </a:prstGeom>
+          <a:noFill/>
+        </p:spPr>
+        <p:txBody>
+          <a:bodyPr wrap="square">
+            <a:spAutoFit/>
+          </a:bodyPr>
+          <a:lstStyle/>
+          <a:p>
+            <a:pPr>
+              <a:defRPr sz="3000" b="1"/>
+            </a:pPr>
+            <a:r>
+              <a:t>Elige tu plan</a:t>
+            </a:r>
+          </a:p>
+          <a:p>
+            <a:pPr>
+              <a:defRPr sz="1800"/>
+            </a:pPr>
+            <a:r>
+              <a:t>Free: para empezar</a:t>
+            </a:r>
+          </a:p>
+          <a:p>
+            <a:pPr>
+              <a:defRPr sz="1800"/>
+            </a:pPr>
+            <a:r>
+              <a:t>Starter y Pro: equipos en crecimiento</a:t>
+            </a:r>
+          </a:p>
+          <a:p>
+            <a:pPr>
+              <a:defRPr sz="1800"/>
+            </a:pPr>
+            <a:r>
+              <a:t>Business: roles, reportes y auditoría</a:t>
+            </a:r>
+          </a:p>
+          <a:p>
+            <a:pPr>
+              <a:defRPr sz="1800"/>
+            </a:pPr>
+            <a:r>
+              <a:t>Enterprise: SSO, SLA 99.95% y soporte 24/7</a:t>
+            </a:r>
+          </a:p>
+        </p:txBody>
+      </p:sp>
+    </p:spTree>
+  </p:cSld>
+  <p:clrMapOvr>
+    <a:masterClrMapping/>
+  </p:clrMapOvr>
+</p:sld>
+</file>
+
+<file path=ppt/slides/slide6.xml><?xml version="1.0" encoding="utf-8"?>
+<p:sld xmlns:a="http://schemas.openxmlformats.org/drawingml/2006/main" xmlns:p="http://schemas.openxmlformats.org/presentationml/2006/main" xmlns:r="http://schemas.openxmlformats.org/officeDocument/2006/relationships">
+  <p:cSld>
+    <p:spTree>
+      <p:nvGrpSpPr>
+        <p:cNvPr id="1" name=""/>
+        <p:cNvGrpSpPr/>
+        <p:nvPr/>
+      </p:nvGrpSpPr>
+      <p:grpSpPr/>
+      <p:sp>
+        <p:nvSpPr>
+          <p:cNvPr id="2" name="TextBox 1"/>
+          <p:cNvSpPr txBox="1"/>
+          <p:nvPr/>
+        </p:nvSpPr>
+        <p:spPr>
+          <a:xfrm>
+            <a:off x="548640" y="365760"/>
+            <a:ext cx="8229600" cy="5486400"/>
+          </a:xfrm>
+          <a:prstGeom prst="rect">
+            <a:avLst/>
+          </a:prstGeom>
+          <a:noFill/>
+        </p:spPr>
+        <p:txBody>
+          <a:bodyPr wrap="square">
+            <a:spAutoFit/>
+          </a:bodyPr>
+          <a:lstStyle/>
+          <a:p>
+            <a:pPr>
+              <a:defRPr sz="3000" b="1"/>
+            </a:pPr>
+            <a:r>
+              <a:t>¿Necesitás ayuda?</a:t>
+            </a:r>
+          </a:p>
+          <a:p>
+            <a:pPr>
+              <a:defRPr sz="1800"/>
+            </a:pPr>
+            <a:r>
+              <a:t>Centro de ayuda y FAQ dentro de la app</a:t>
+            </a:r>
+          </a:p>
+          <a:p>
+            <a:pPr>
+              <a:defRPr sz="1800"/>
+            </a:pPr>
+            <a:r>
+              <a:t>soporte@technova.com</a:t>
+            </a:r>
+          </a:p>
+          <a:p>
+            <a:pPr>
+              <a:defRPr sz="1800"/>
+            </a:pPr>
+            <a:r>
+              <a:t>Estado del servicio: status.technova.com</a:t>
             </a:r>
           </a:p>
         </p:txBody>

</xml_diff>